<commit_message>
Presentation: update to final 30-patient results (VGG11 0.797)
Co-Authored-By: Claude Opus 4.8 <noreply@anthropic.com>
</commit_message>
<xml_diff>
--- a/docs/presentation.pptx
+++ b/docs/presentation.pptx
@@ -606,13 +606,13 @@
                 <c:formatCode>General</c:formatCode>
                 <c:ptCount val="3"/>
                 <c:pt idx="0">
-                  <c:v>0.869</c:v>
+                  <c:v>0.725</c:v>
                 </c:pt>
                 <c:pt idx="1">
-                  <c:v>0.924</c:v>
+                  <c:v>0.797</c:v>
                 </c:pt>
                 <c:pt idx="2">
-                  <c:v>0.911</c:v>
+                  <c:v>0.724</c:v>
                 </c:pt>
               </c:numCache>
             </c:numRef>
@@ -3791,7 +3791,7 @@
                 <a:ea typeface="Calibri" pitchFamily="34" charset="-122"/>
                 <a:cs typeface="Calibri" pitchFamily="34" charset="-120"/>
               </a:rPr>
-              <a:t>VGG11 е най-добрият модел (Cohen Kappa 0.924) на невиждани пациенти.
+              <a:t>VGG11 е най-добрият модел (Cohen Kappa 0.797 на 30 невиждани пациента).
 </a:t>
             </a:r>
             <a:endParaRPr lang="en-US" sz="1600" dirty="0"/>
@@ -9001,7 +9001,7 @@
                 <a:ea typeface="Calibri" pitchFamily="34" charset="-122"/>
                 <a:cs typeface="Calibri" pitchFamily="34" charset="-120"/>
               </a:rPr>
-              <a:t>Cohen Kappa, patient-level split, най-добър checkpoint</a:t>
+              <a:t>Cohen Kappa · 30 пациента · 44 321 патча · patient-level split</a:t>
             </a:r>
             <a:endParaRPr lang="en-US" sz="1400" dirty="0"/>
           </a:p>
@@ -9106,7 +9106,7 @@
                 <a:ea typeface="Georgia" pitchFamily="34" charset="-122"/>
                 <a:cs typeface="Georgia" pitchFamily="34" charset="-120"/>
               </a:rPr>
-              <a:t>най-добър · κ = 0.924</a:t>
+              <a:t>най-добър · κ = 0.797</a:t>
             </a:r>
             <a:endParaRPr lang="en-US" sz="2000" dirty="0"/>
           </a:p>
@@ -9169,7 +9169,7 @@
                 <a:ea typeface="Calibri" pitchFamily="34" charset="-122"/>
                 <a:cs typeface="Calibri" pitchFamily="34" charset="-120"/>
               </a:rPr>
-              <a:t>CNN се вдигна от случайност (−0.05) до 0.87 след stain аугментация.</a:t>
+              <a:t>CNN се вдигна от случайност (−0.05) до 0.73 след stain аугментация.</a:t>
             </a:r>
             <a:endParaRPr lang="en-US" sz="1250" dirty="0"/>
           </a:p>

</xml_diff>

<commit_message>
Tone down presentation and docstrings to neutral/academic register
Co-Authored-By: Claude Opus 4.8 <noreply@anthropic.com>
</commit_message>
<xml_diff>
--- a/docs/presentation.pptx
+++ b/docs/presentation.pptx
@@ -3408,7 +3408,7 @@
                 <a:ea typeface="Georgia" pitchFamily="34" charset="-122"/>
                 <a:cs typeface="Georgia" pitchFamily="34" charset="-120"/>
               </a:rPr>
-              <a:t>🔬 Качи патч → предсказание</a:t>
+              <a:t>Качване на патч и предсказание</a:t>
             </a:r>
             <a:endParaRPr lang="en-US" sz="1500" dirty="0"/>
           </a:p>
@@ -7672,7 +7672,7 @@
                 <a:ea typeface="Georgia" pitchFamily="34" charset="-122"/>
                 <a:cs typeface="Georgia" pitchFamily="34" charset="-120"/>
               </a:rPr>
-              <a:t>★ Ключова находка: изтичане на информация</a:t>
+              <a:t>Изтичане на информация при оценката</a:t>
             </a:r>
             <a:endParaRPr lang="en-US" sz="2800" dirty="0"/>
           </a:p>
@@ -7711,7 +7711,7 @@
                 <a:ea typeface="Calibri" pitchFamily="34" charset="-122"/>
                 <a:cs typeface="Calibri" pitchFamily="34" charset="-120"/>
               </a:rPr>
-              <a:t>Методологията се оказа по-важна от архитектурата</a:t>
+              <a:t>Влияние на начина на разделяне на данните върху резултата</a:t>
             </a:r>
             <a:endParaRPr lang="en-US" sz="1400" dirty="0"/>
           </a:p>
@@ -9106,7 +9106,7 @@
                 <a:ea typeface="Georgia" pitchFamily="34" charset="-122"/>
                 <a:cs typeface="Georgia" pitchFamily="34" charset="-120"/>
               </a:rPr>
-              <a:t>най-добър · κ = 0.797</a:t>
+              <a:t>най-висок κ = 0.797</a:t>
             </a:r>
             <a:endParaRPr lang="en-US" sz="2000" dirty="0"/>
           </a:p>

</xml_diff>